<commit_message>
Colocando as imagens criadas
</commit_message>
<xml_diff>
--- a/output/ebook - templateAndre.pptx
+++ b/output/ebook - templateAndre.pptx
@@ -7451,8 +7451,8 @@
         </p:blipFill>
         <p:spPr>
           <a:xfrm>
-            <a:off x="0" y="0"/>
-            <a:ext cx="6858000" cy="9906000"/>
+            <a:off x="-105726" y="0"/>
+            <a:ext cx="7068730" cy="9906000"/>
           </a:xfrm>
           <a:prstGeom prst="rect">
             <a:avLst/>

</xml_diff>